<commit_message>
implemented vectorized accuracy + minor improvements
</commit_message>
<xml_diff>
--- a/docs/Schémas_et_formules_mathématiques.pptx
+++ b/docs/Schémas_et_formules_mathématiques.pptx
@@ -307,7 +307,7 @@
           <a:p>
             <a:fld id="{8CC8168F-B74C-4525-A6F8-EBA84798C097}" type="datetimeFigureOut">
               <a:rPr lang="fr-FR" smtClean="0"/>
-              <a:t>09/06/2025</a:t>
+              <a:t>03/08/2025</a:t>
             </a:fld>
             <a:endParaRPr lang="fr-FR"/>
           </a:p>
@@ -505,7 +505,7 @@
           <a:p>
             <a:fld id="{8CC8168F-B74C-4525-A6F8-EBA84798C097}" type="datetimeFigureOut">
               <a:rPr lang="fr-FR" smtClean="0"/>
-              <a:t>09/06/2025</a:t>
+              <a:t>03/08/2025</a:t>
             </a:fld>
             <a:endParaRPr lang="fr-FR"/>
           </a:p>
@@ -713,7 +713,7 @@
           <a:p>
             <a:fld id="{8CC8168F-B74C-4525-A6F8-EBA84798C097}" type="datetimeFigureOut">
               <a:rPr lang="fr-FR" smtClean="0"/>
-              <a:t>09/06/2025</a:t>
+              <a:t>03/08/2025</a:t>
             </a:fld>
             <a:endParaRPr lang="fr-FR"/>
           </a:p>
@@ -911,7 +911,7 @@
           <a:p>
             <a:fld id="{8CC8168F-B74C-4525-A6F8-EBA84798C097}" type="datetimeFigureOut">
               <a:rPr lang="fr-FR" smtClean="0"/>
-              <a:t>09/06/2025</a:t>
+              <a:t>03/08/2025</a:t>
             </a:fld>
             <a:endParaRPr lang="fr-FR"/>
           </a:p>
@@ -1186,7 +1186,7 @@
           <a:p>
             <a:fld id="{8CC8168F-B74C-4525-A6F8-EBA84798C097}" type="datetimeFigureOut">
               <a:rPr lang="fr-FR" smtClean="0"/>
-              <a:t>09/06/2025</a:t>
+              <a:t>03/08/2025</a:t>
             </a:fld>
             <a:endParaRPr lang="fr-FR"/>
           </a:p>
@@ -1451,7 +1451,7 @@
           <a:p>
             <a:fld id="{8CC8168F-B74C-4525-A6F8-EBA84798C097}" type="datetimeFigureOut">
               <a:rPr lang="fr-FR" smtClean="0"/>
-              <a:t>09/06/2025</a:t>
+              <a:t>03/08/2025</a:t>
             </a:fld>
             <a:endParaRPr lang="fr-FR"/>
           </a:p>
@@ -1863,7 +1863,7 @@
           <a:p>
             <a:fld id="{8CC8168F-B74C-4525-A6F8-EBA84798C097}" type="datetimeFigureOut">
               <a:rPr lang="fr-FR" smtClean="0"/>
-              <a:t>09/06/2025</a:t>
+              <a:t>03/08/2025</a:t>
             </a:fld>
             <a:endParaRPr lang="fr-FR"/>
           </a:p>
@@ -2004,7 +2004,7 @@
           <a:p>
             <a:fld id="{8CC8168F-B74C-4525-A6F8-EBA84798C097}" type="datetimeFigureOut">
               <a:rPr lang="fr-FR" smtClean="0"/>
-              <a:t>09/06/2025</a:t>
+              <a:t>03/08/2025</a:t>
             </a:fld>
             <a:endParaRPr lang="fr-FR"/>
           </a:p>
@@ -2117,7 +2117,7 @@
           <a:p>
             <a:fld id="{8CC8168F-B74C-4525-A6F8-EBA84798C097}" type="datetimeFigureOut">
               <a:rPr lang="fr-FR" smtClean="0"/>
-              <a:t>09/06/2025</a:t>
+              <a:t>03/08/2025</a:t>
             </a:fld>
             <a:endParaRPr lang="fr-FR"/>
           </a:p>
@@ -2428,7 +2428,7 @@
           <a:p>
             <a:fld id="{8CC8168F-B74C-4525-A6F8-EBA84798C097}" type="datetimeFigureOut">
               <a:rPr lang="fr-FR" smtClean="0"/>
-              <a:t>09/06/2025</a:t>
+              <a:t>03/08/2025</a:t>
             </a:fld>
             <a:endParaRPr lang="fr-FR"/>
           </a:p>
@@ -2716,7 +2716,7 @@
           <a:p>
             <a:fld id="{8CC8168F-B74C-4525-A6F8-EBA84798C097}" type="datetimeFigureOut">
               <a:rPr lang="fr-FR" smtClean="0"/>
-              <a:t>09/06/2025</a:t>
+              <a:t>03/08/2025</a:t>
             </a:fld>
             <a:endParaRPr lang="fr-FR"/>
           </a:p>
@@ -2957,7 +2957,7 @@
           <a:p>
             <a:fld id="{8CC8168F-B74C-4525-A6F8-EBA84798C097}" type="datetimeFigureOut">
               <a:rPr lang="fr-FR" smtClean="0"/>
-              <a:t>09/06/2025</a:t>
+              <a:t>03/08/2025</a:t>
             </a:fld>
             <a:endParaRPr lang="fr-FR"/>
           </a:p>
@@ -18506,8 +18506,8 @@
           </a:p>
         </p:txBody>
       </p:sp>
-      <mc:AlternateContent xmlns:mc="http://schemas.openxmlformats.org/markup-compatibility/2006">
-        <mc:Choice xmlns:a14="http://schemas.microsoft.com/office/drawing/2010/main" Requires="a14">
+      <mc:AlternateContent xmlns:mc="http://schemas.openxmlformats.org/markup-compatibility/2006" xmlns:a14="http://schemas.microsoft.com/office/drawing/2010/main">
+        <mc:Choice Requires="a14">
           <p:sp>
             <p:nvSpPr>
               <p:cNvPr id="93" name="ZoneTexte 92">
@@ -18884,19 +18884,7 @@
                       <a:rPr lang="fr-FR" b="0" i="1" smtClean="0">
                         <a:latin typeface="Cambria Math" panose="02040503050406030204" pitchFamily="18" charset="0"/>
                       </a:rPr>
-                      <m:t> </m:t>
-                    </m:r>
-                    <m:r>
-                      <a:rPr lang="fr-FR" b="0" i="1" smtClean="0">
-                        <a:latin typeface="Cambria Math" panose="02040503050406030204" pitchFamily="18" charset="0"/>
-                      </a:rPr>
-                      <m:t>   </m:t>
-                    </m:r>
-                    <m:r>
-                      <a:rPr lang="fr-FR" b="0" i="1" smtClean="0">
-                        <a:latin typeface="Cambria Math" panose="02040503050406030204" pitchFamily="18" charset="0"/>
-                      </a:rPr>
-                      <m:t>(</m:t>
+                      <m:t>    (</m:t>
                     </m:r>
                     <m:r>
                       <a:rPr lang="fr-FR" b="0" i="1" smtClean="0">
@@ -19155,7 +19143,7 @@
             </p:txBody>
           </p:sp>
         </mc:Choice>
-        <mc:Fallback>
+        <mc:Fallback xmlns="">
           <p:sp>
             <p:nvSpPr>
               <p:cNvPr id="93" name="ZoneTexte 92">
@@ -20376,8 +20364,8 @@
           </p:sp>
         </mc:Fallback>
       </mc:AlternateContent>
-      <mc:AlternateContent xmlns:mc="http://schemas.openxmlformats.org/markup-compatibility/2006" xmlns:a14="http://schemas.microsoft.com/office/drawing/2010/main">
-        <mc:Choice Requires="a14">
+      <mc:AlternateContent xmlns:mc="http://schemas.openxmlformats.org/markup-compatibility/2006">
+        <mc:Choice xmlns:a14="http://schemas.microsoft.com/office/drawing/2010/main" Requires="a14">
           <p:sp>
             <p:nvSpPr>
               <p:cNvPr id="95" name="ZoneTexte 94">
@@ -20393,7 +20381,7 @@
             <p:spPr>
               <a:xfrm>
                 <a:off x="4997450" y="73762"/>
-                <a:ext cx="6765289" cy="5027467"/>
+                <a:ext cx="6765289" cy="5904501"/>
               </a:xfrm>
               <a:prstGeom prst="rect">
                 <a:avLst/>
@@ -22899,6 +22887,528 @@
                 </a:endParaRPr>
               </a:p>
               <a:p>
+                <a:pPr/>
+                <a14:m>
+                  <m:oMathPara xmlns:m="http://schemas.openxmlformats.org/officeDocument/2006/math">
+                    <m:oMathParaPr>
+                      <m:jc m:val="left"/>
+                    </m:oMathParaPr>
+                    <m:oMath xmlns:m="http://schemas.openxmlformats.org/officeDocument/2006/math">
+                      <m:borderBox>
+                        <m:borderBoxPr>
+                          <m:ctrlPr>
+                            <a:rPr lang="fr-FR" sz="1800" i="1" smtClean="0">
+                              <a:solidFill>
+                                <a:schemeClr val="tx1">
+                                  <a:lumMod val="65000"/>
+                                  <a:lumOff val="35000"/>
+                                </a:schemeClr>
+                              </a:solidFill>
+                              <a:effectLst/>
+                              <a:latin typeface="Cambria Math" panose="02040503050406030204" pitchFamily="18" charset="0"/>
+                              <a:ea typeface="Cambria Math" panose="02040503050406030204" pitchFamily="18" charset="0"/>
+                            </a:rPr>
+                          </m:ctrlPr>
+                        </m:borderBoxPr>
+                        <m:e>
+                          <m:sSup>
+                            <m:sSupPr>
+                              <m:ctrlPr>
+                                <a:rPr lang="x-IV_mathan" i="1">
+                                  <a:solidFill>
+                                    <a:schemeClr val="tx1">
+                                      <a:lumMod val="65000"/>
+                                      <a:lumOff val="35000"/>
+                                    </a:schemeClr>
+                                  </a:solidFill>
+                                  <a:latin typeface="Cambria Math" panose="02040503050406030204" pitchFamily="18" charset="0"/>
+                                  <a:ea typeface="Cambria Math" panose="02040503050406030204" pitchFamily="18" charset="0"/>
+                                </a:rPr>
+                              </m:ctrlPr>
+                            </m:sSupPr>
+                            <m:e>
+                              <m:r>
+                                <a:rPr lang="x-IV_mathan" i="1">
+                                  <a:solidFill>
+                                    <a:schemeClr val="tx1">
+                                      <a:lumMod val="65000"/>
+                                      <a:lumOff val="35000"/>
+                                    </a:schemeClr>
+                                  </a:solidFill>
+                                  <a:latin typeface="Cambria Math" panose="02040503050406030204" pitchFamily="18" charset="0"/>
+                                  <a:ea typeface="Cambria Math" panose="02040503050406030204" pitchFamily="18" charset="0"/>
+                                </a:rPr>
+                                <m:t> </m:t>
+                              </m:r>
+                              <m:r>
+                                <a:rPr lang="x-IV_mathan">
+                                  <a:solidFill>
+                                    <a:schemeClr val="tx1">
+                                      <a:lumMod val="65000"/>
+                                      <a:lumOff val="35000"/>
+                                    </a:schemeClr>
+                                  </a:solidFill>
+                                  <a:latin typeface="Cambria Math" panose="02040503050406030204" pitchFamily="18" charset="0"/>
+                                  <a:ea typeface="Cambria Math" panose="02040503050406030204" pitchFamily="18" charset="0"/>
+                                </a:rPr>
+                                <m:t>𝑍</m:t>
+                              </m:r>
+                            </m:e>
+                            <m:sup>
+                              <m:r>
+                                <a:rPr lang="x-IV_mathan">
+                                  <a:solidFill>
+                                    <a:schemeClr val="tx1">
+                                      <a:lumMod val="65000"/>
+                                      <a:lumOff val="35000"/>
+                                    </a:schemeClr>
+                                  </a:solidFill>
+                                  <a:latin typeface="Cambria Math" panose="02040503050406030204" pitchFamily="18" charset="0"/>
+                                  <a:ea typeface="Cambria Math" panose="02040503050406030204" pitchFamily="18" charset="0"/>
+                                </a:rPr>
+                                <m:t>𝑖</m:t>
+                              </m:r>
+                            </m:sup>
+                          </m:sSup>
+                          <m:r>
+                            <a:rPr lang="x-IV_mathan">
+                              <a:solidFill>
+                                <a:schemeClr val="tx1">
+                                  <a:lumMod val="65000"/>
+                                  <a:lumOff val="35000"/>
+                                </a:schemeClr>
+                              </a:solidFill>
+                              <a:latin typeface="Cambria Math" panose="02040503050406030204" pitchFamily="18" charset="0"/>
+                              <a:ea typeface="Cambria Math" panose="02040503050406030204" pitchFamily="18" charset="0"/>
+                            </a:rPr>
+                            <m:t>=</m:t>
+                          </m:r>
+                          <m:sSup>
+                            <m:sSupPr>
+                              <m:ctrlPr>
+                                <a:rPr lang="x-IV_mathan" i="1">
+                                  <a:solidFill>
+                                    <a:schemeClr val="tx1">
+                                      <a:lumMod val="65000"/>
+                                      <a:lumOff val="35000"/>
+                                    </a:schemeClr>
+                                  </a:solidFill>
+                                  <a:latin typeface="Cambria Math" panose="02040503050406030204" pitchFamily="18" charset="0"/>
+                                  <a:ea typeface="Cambria Math" panose="02040503050406030204" pitchFamily="18" charset="0"/>
+                                </a:rPr>
+                              </m:ctrlPr>
+                            </m:sSupPr>
+                            <m:e>
+                              <m:r>
+                                <a:rPr lang="x-IV_mathan">
+                                  <a:solidFill>
+                                    <a:schemeClr val="tx1">
+                                      <a:lumMod val="65000"/>
+                                      <a:lumOff val="35000"/>
+                                    </a:schemeClr>
+                                  </a:solidFill>
+                                  <a:latin typeface="Cambria Math" panose="02040503050406030204" pitchFamily="18" charset="0"/>
+                                  <a:ea typeface="Cambria Math" panose="02040503050406030204" pitchFamily="18" charset="0"/>
+                                </a:rPr>
+                                <m:t>𝐴</m:t>
+                              </m:r>
+                            </m:e>
+                            <m:sup>
+                              <m:r>
+                                <a:rPr lang="x-IV_mathan">
+                                  <a:solidFill>
+                                    <a:schemeClr val="tx1">
+                                      <a:lumMod val="65000"/>
+                                      <a:lumOff val="35000"/>
+                                    </a:schemeClr>
+                                  </a:solidFill>
+                                  <a:latin typeface="Cambria Math" panose="02040503050406030204" pitchFamily="18" charset="0"/>
+                                  <a:ea typeface="Cambria Math" panose="02040503050406030204" pitchFamily="18" charset="0"/>
+                                </a:rPr>
+                                <m:t>𝑖</m:t>
+                              </m:r>
+                              <m:r>
+                                <a:rPr lang="x-IV_mathan">
+                                  <a:solidFill>
+                                    <a:schemeClr val="tx1">
+                                      <a:lumMod val="65000"/>
+                                      <a:lumOff val="35000"/>
+                                    </a:schemeClr>
+                                  </a:solidFill>
+                                  <a:latin typeface="Cambria Math" panose="02040503050406030204" pitchFamily="18" charset="0"/>
+                                  <a:ea typeface="Cambria Math" panose="02040503050406030204" pitchFamily="18" charset="0"/>
+                                </a:rPr>
+                                <m:t>−1</m:t>
+                              </m:r>
+                            </m:sup>
+                          </m:sSup>
+                          <m:sSup>
+                            <m:sSupPr>
+                              <m:ctrlPr>
+                                <a:rPr lang="x-IV_mathan" i="1">
+                                  <a:solidFill>
+                                    <a:schemeClr val="tx1">
+                                      <a:lumMod val="65000"/>
+                                      <a:lumOff val="35000"/>
+                                    </a:schemeClr>
+                                  </a:solidFill>
+                                  <a:latin typeface="Cambria Math" panose="02040503050406030204" pitchFamily="18" charset="0"/>
+                                  <a:ea typeface="Cambria Math" panose="02040503050406030204" pitchFamily="18" charset="0"/>
+                                </a:rPr>
+                              </m:ctrlPr>
+                            </m:sSupPr>
+                            <m:e>
+                              <m:sSup>
+                                <m:sSupPr>
+                                  <m:ctrlPr>
+                                    <a:rPr lang="x-IV_mathan" i="1">
+                                      <a:solidFill>
+                                        <a:schemeClr val="tx1">
+                                          <a:lumMod val="65000"/>
+                                          <a:lumOff val="35000"/>
+                                        </a:schemeClr>
+                                      </a:solidFill>
+                                      <a:latin typeface="Cambria Math" panose="02040503050406030204" pitchFamily="18" charset="0"/>
+                                      <a:ea typeface="Cambria Math" panose="02040503050406030204" pitchFamily="18" charset="0"/>
+                                    </a:rPr>
+                                  </m:ctrlPr>
+                                </m:sSupPr>
+                                <m:e>
+                                  <m:r>
+                                    <a:rPr lang="x-IV_mathan">
+                                      <a:solidFill>
+                                        <a:schemeClr val="tx1">
+                                          <a:lumMod val="65000"/>
+                                          <a:lumOff val="35000"/>
+                                        </a:schemeClr>
+                                      </a:solidFill>
+                                      <a:latin typeface="Cambria Math" panose="02040503050406030204" pitchFamily="18" charset="0"/>
+                                      <a:ea typeface="Cambria Math" panose="02040503050406030204" pitchFamily="18" charset="0"/>
+                                    </a:rPr>
+                                    <m:t>𝑊</m:t>
+                                  </m:r>
+                                </m:e>
+                                <m:sup>
+                                  <m:r>
+                                    <a:rPr lang="x-IV_mathan">
+                                      <a:solidFill>
+                                        <a:schemeClr val="tx1">
+                                          <a:lumMod val="65000"/>
+                                          <a:lumOff val="35000"/>
+                                        </a:schemeClr>
+                                      </a:solidFill>
+                                      <a:latin typeface="Cambria Math" panose="02040503050406030204" pitchFamily="18" charset="0"/>
+                                      <a:ea typeface="Cambria Math" panose="02040503050406030204" pitchFamily="18" charset="0"/>
+                                    </a:rPr>
+                                    <m:t>𝑖</m:t>
+                                  </m:r>
+                                </m:sup>
+                              </m:sSup>
+                            </m:e>
+                            <m:sup>
+                              <m:r>
+                                <a:rPr lang="x-IV_mathan">
+                                  <a:solidFill>
+                                    <a:schemeClr val="tx1">
+                                      <a:lumMod val="65000"/>
+                                      <a:lumOff val="35000"/>
+                                    </a:schemeClr>
+                                  </a:solidFill>
+                                  <a:latin typeface="Cambria Math" panose="02040503050406030204" pitchFamily="18" charset="0"/>
+                                  <a:ea typeface="Cambria Math" panose="02040503050406030204" pitchFamily="18" charset="0"/>
+                                </a:rPr>
+                                <m:t>𝑇</m:t>
+                              </m:r>
+                            </m:sup>
+                          </m:sSup>
+                          <m:r>
+                            <a:rPr lang="x-IV_mathan">
+                              <a:solidFill>
+                                <a:schemeClr val="tx1">
+                                  <a:lumMod val="65000"/>
+                                  <a:lumOff val="35000"/>
+                                </a:schemeClr>
+                              </a:solidFill>
+                              <a:latin typeface="Cambria Math" panose="02040503050406030204" pitchFamily="18" charset="0"/>
+                              <a:ea typeface="Cambria Math" panose="02040503050406030204" pitchFamily="18" charset="0"/>
+                            </a:rPr>
+                            <m:t>−</m:t>
+                          </m:r>
+                          <m:sSup>
+                            <m:sSupPr>
+                              <m:ctrlPr>
+                                <a:rPr lang="x-IV_mathan" i="1">
+                                  <a:solidFill>
+                                    <a:schemeClr val="tx1">
+                                      <a:lumMod val="65000"/>
+                                      <a:lumOff val="35000"/>
+                                    </a:schemeClr>
+                                  </a:solidFill>
+                                  <a:latin typeface="Cambria Math" panose="02040503050406030204" pitchFamily="18" charset="0"/>
+                                  <a:ea typeface="Cambria Math" panose="02040503050406030204" pitchFamily="18" charset="0"/>
+                                </a:rPr>
+                              </m:ctrlPr>
+                            </m:sSupPr>
+                            <m:e>
+                              <m:r>
+                                <a:rPr lang="x-IV_mathan">
+                                  <a:solidFill>
+                                    <a:schemeClr val="tx1">
+                                      <a:lumMod val="65000"/>
+                                      <a:lumOff val="35000"/>
+                                    </a:schemeClr>
+                                  </a:solidFill>
+                                  <a:latin typeface="Cambria Math" panose="02040503050406030204" pitchFamily="18" charset="0"/>
+                                  <a:ea typeface="Cambria Math" panose="02040503050406030204" pitchFamily="18" charset="0"/>
+                                </a:rPr>
+                                <m:t>𝐵</m:t>
+                              </m:r>
+                            </m:e>
+                            <m:sup>
+                              <m:r>
+                                <a:rPr lang="x-IV_mathan">
+                                  <a:solidFill>
+                                    <a:schemeClr val="tx1">
+                                      <a:lumMod val="65000"/>
+                                      <a:lumOff val="35000"/>
+                                    </a:schemeClr>
+                                  </a:solidFill>
+                                  <a:latin typeface="Cambria Math" panose="02040503050406030204" pitchFamily="18" charset="0"/>
+                                  <a:ea typeface="Cambria Math" panose="02040503050406030204" pitchFamily="18" charset="0"/>
+                                </a:rPr>
+                                <m:t>𝑖</m:t>
+                              </m:r>
+                            </m:sup>
+                          </m:sSup>
+                          <m:r>
+                            <m:rPr>
+                              <m:nor/>
+                            </m:rPr>
+                            <a:rPr lang="fr-FR" b="0" i="0" smtClean="0">
+                              <a:solidFill>
+                                <a:schemeClr val="tx1">
+                                  <a:lumMod val="65000"/>
+                                  <a:lumOff val="35000"/>
+                                </a:schemeClr>
+                              </a:solidFill>
+                              <a:latin typeface="Cambria Math" panose="02040503050406030204" pitchFamily="18" charset="0"/>
+                              <a:ea typeface="Cambria Math" panose="02040503050406030204" pitchFamily="18" charset="0"/>
+                            </a:rPr>
+                            <m:t> (</m:t>
+                          </m:r>
+                          <m:r>
+                            <m:rPr>
+                              <m:nor/>
+                            </m:rPr>
+                            <a:rPr lang="fr-FR" b="0" i="0" smtClean="0">
+                              <a:solidFill>
+                                <a:schemeClr val="tx1">
+                                  <a:lumMod val="65000"/>
+                                  <a:lumOff val="35000"/>
+                                </a:schemeClr>
+                              </a:solidFill>
+                              <a:latin typeface="Cambria Math" panose="02040503050406030204" pitchFamily="18" charset="0"/>
+                              <a:ea typeface="Cambria Math" panose="02040503050406030204" pitchFamily="18" charset="0"/>
+                            </a:rPr>
+                            <m:t>l</m:t>
+                          </m:r>
+                          <m:r>
+                            <m:rPr>
+                              <m:nor/>
+                            </m:rPr>
+                            <a:rPr lang="fr-FR" b="0" i="0" smtClean="0">
+                              <a:solidFill>
+                                <a:schemeClr val="tx1">
+                                  <a:lumMod val="65000"/>
+                                  <a:lumOff val="35000"/>
+                                </a:schemeClr>
+                              </a:solidFill>
+                              <a:latin typeface="Cambria Math" panose="02040503050406030204" pitchFamily="18" charset="0"/>
+                              <a:ea typeface="Cambria Math" panose="02040503050406030204" pitchFamily="18" charset="0"/>
+                            </a:rPr>
+                            <m:t>)</m:t>
+                          </m:r>
+                          <m:r>
+                            <m:rPr>
+                              <m:nor/>
+                            </m:rPr>
+                            <a:rPr lang="x-IV_mathan">
+                              <a:solidFill>
+                                <a:schemeClr val="tx1">
+                                  <a:lumMod val="65000"/>
+                                  <a:lumOff val="35000"/>
+                                </a:schemeClr>
+                              </a:solidFill>
+                              <a:latin typeface="Cambria Math" panose="02040503050406030204" pitchFamily="18" charset="0"/>
+                              <a:ea typeface="Cambria Math" panose="02040503050406030204" pitchFamily="18" charset="0"/>
+                            </a:rPr>
+                            <m:t> </m:t>
+                          </m:r>
+                        </m:e>
+                      </m:borderBox>
+                    </m:oMath>
+                  </m:oMathPara>
+                </a14:m>
+                <a:endParaRPr lang="fr-FR" sz="1800" dirty="0">
+                  <a:solidFill>
+                    <a:schemeClr val="tx1">
+                      <a:lumMod val="65000"/>
+                      <a:lumOff val="35000"/>
+                    </a:schemeClr>
+                  </a:solidFill>
+                  <a:effectLst/>
+                  <a:latin typeface="Cambria Math" panose="02040503050406030204" pitchFamily="18" charset="0"/>
+                  <a:ea typeface="Cambria Math" panose="02040503050406030204" pitchFamily="18" charset="0"/>
+                </a:endParaRPr>
+              </a:p>
+              <a:p>
+                <a:endParaRPr lang="fr-FR" sz="1800" dirty="0">
+                  <a:solidFill>
+                    <a:srgbClr val="44546A"/>
+                  </a:solidFill>
+                  <a:effectLst/>
+                  <a:latin typeface="Cambria Math" panose="02040503050406030204" pitchFamily="18" charset="0"/>
+                </a:endParaRPr>
+              </a:p>
+              <a:p>
+                <a:pPr/>
+                <a14:m>
+                  <m:oMathPara xmlns:m="http://schemas.openxmlformats.org/officeDocument/2006/math">
+                    <m:oMathParaPr>
+                      <m:jc m:val="left"/>
+                    </m:oMathParaPr>
+                    <m:oMath xmlns:m="http://schemas.openxmlformats.org/officeDocument/2006/math">
+                      <m:borderBox>
+                        <m:borderBoxPr>
+                          <m:ctrlPr>
+                            <a:rPr lang="fr-FR" sz="1800" i="1" smtClean="0">
+                              <a:solidFill>
+                                <a:srgbClr val="44546A"/>
+                              </a:solidFill>
+                              <a:effectLst/>
+                              <a:latin typeface="Cambria Math" panose="02040503050406030204" pitchFamily="18" charset="0"/>
+                            </a:rPr>
+                          </m:ctrlPr>
+                        </m:borderBoxPr>
+                        <m:e>
+                          <m:sSup>
+                            <m:sSupPr>
+                              <m:ctrlPr>
+                                <a:rPr lang="x-IV_mathan" i="1"/>
+                              </m:ctrlPr>
+                            </m:sSupPr>
+                            <m:e>
+                              <m:r>
+                                <a:rPr lang="x-IV_mathan"/>
+                                <m:t>𝐙</m:t>
+                              </m:r>
+                            </m:e>
+                            <m:sup>
+                              <m:r>
+                                <a:rPr lang="x-IV_mathan"/>
+                                <m:t>𝐢</m:t>
+                              </m:r>
+                            </m:sup>
+                          </m:sSup>
+                          <m:r>
+                            <a:rPr lang="x-IV_mathan"/>
+                            <m:t>=</m:t>
+                          </m:r>
+                          <m:sSup>
+                            <m:sSupPr>
+                              <m:ctrlPr>
+                                <a:rPr lang="x-IV_mathan" i="1"/>
+                              </m:ctrlPr>
+                            </m:sSupPr>
+                            <m:e>
+                              <m:r>
+                                <a:rPr lang="x-IV_mathan"/>
+                                <m:t>𝐀</m:t>
+                              </m:r>
+                            </m:e>
+                            <m:sup>
+                              <m:r>
+                                <a:rPr lang="x-IV_mathan"/>
+                                <m:t>𝐢</m:t>
+                              </m:r>
+                              <m:r>
+                                <a:rPr lang="fr-FR" b="0" i="1" smtClean="0">
+                                  <a:latin typeface="Cambria Math" panose="02040503050406030204" pitchFamily="18" charset="0"/>
+                                </a:rPr>
+                                <m:t>−1</m:t>
+                              </m:r>
+                            </m:sup>
+                          </m:sSup>
+                          <m:sSup>
+                            <m:sSupPr>
+                              <m:ctrlPr>
+                                <a:rPr lang="x-IV_mathan" i="1"/>
+                              </m:ctrlPr>
+                            </m:sSupPr>
+                            <m:e>
+                              <m:sSup>
+                                <m:sSupPr>
+                                  <m:ctrlPr>
+                                    <a:rPr lang="x-IV_mathan" i="1"/>
+                                  </m:ctrlPr>
+                                </m:sSupPr>
+                                <m:e>
+                                  <m:r>
+                                    <a:rPr lang="x-IV_mathan"/>
+                                    <m:t>𝑊</m:t>
+                                  </m:r>
+                                </m:e>
+                                <m:sup>
+                                  <m:r>
+                                    <a:rPr lang="x-IV_mathan"/>
+                                    <m:t>𝑖</m:t>
+                                  </m:r>
+                                </m:sup>
+                              </m:sSup>
+                            </m:e>
+                            <m:sup>
+                              <m:r>
+                                <a:rPr lang="x-IV_mathan"/>
+                                <m:t>𝑇</m:t>
+                              </m:r>
+                            </m:sup>
+                          </m:sSup>
+                          <m:r>
+                            <a:rPr lang="x-IV_mathan" i="1"/>
+                            <m:t> </m:t>
+                          </m:r>
+                          <m:r>
+                            <a:rPr lang="x-IV_mathan"/>
+                            <m:t>−</m:t>
+                          </m:r>
+                          <m:r>
+                            <a:rPr lang="x-IV_mathan" i="1"/>
+                            <m:t> </m:t>
+                          </m:r>
+                          <m:sSup>
+                            <m:sSupPr>
+                              <m:ctrlPr>
+                                <a:rPr lang="x-IV_mathan" i="1"/>
+                              </m:ctrlPr>
+                            </m:sSupPr>
+                            <m:e>
+                              <m:r>
+                                <a:rPr lang="x-IV_mathan"/>
+                                <m:t>𝐁</m:t>
+                              </m:r>
+                            </m:e>
+                            <m:sup>
+                              <m:r>
+                                <a:rPr lang="x-IV_mathan"/>
+                                <m:t>𝐢</m:t>
+                              </m:r>
+                            </m:sup>
+                          </m:sSup>
+                        </m:e>
+                      </m:borderBox>
+                    </m:oMath>
+                  </m:oMathPara>
+                </a14:m>
                 <a:endParaRPr lang="fr-FR" sz="1800" dirty="0">
                   <a:solidFill>
                     <a:srgbClr val="44546A"/>
@@ -22913,7 +23423,7 @@
             </p:txBody>
           </p:sp>
         </mc:Choice>
-        <mc:Fallback xmlns="">
+        <mc:Fallback>
           <p:sp>
             <p:nvSpPr>
               <p:cNvPr id="95" name="ZoneTexte 94">
@@ -22931,7 +23441,7 @@
             <p:spPr>
               <a:xfrm>
                 <a:off x="4997450" y="73762"/>
-                <a:ext cx="6765289" cy="5027467"/>
+                <a:ext cx="6765289" cy="5904501"/>
               </a:xfrm>
               <a:prstGeom prst="rect">
                 <a:avLst/>

</xml_diff>